<commit_message>
Align the wiki-overfit baseline with the codec-only reconstruction; rebuild deck
- wiki_overfit_grounded.py: measure the pure autoencoder path
  (forward_grounded, no loop/memory), matching the post-restructure design;
  --full-bptt is now inert and kept only for old invocations
- regenerate the baseline metrics and comparison.png on that path
- ema_target.py: document why ema_momentum was raised to 0.996 from the
  source paper's 0.98
- build_deck.py + pptx: rebuild the deck
- .gitignore: un-ignore *.pdf (the research PDFs were already tracked)

Co-Authored-By: Claude Fable 5 <noreply@anthropic.com>
</commit_message>
<xml_diff>
--- a/Hierarchical_Latent_Reasoning_Architecture.pptx
+++ b/Hierarchical_Latent_Reasoning_Architecture.pptx
@@ -8602,7 +8602,7 @@
         </p:nvSpPr>
         <p:spPr>
           <a:xfrm>
-            <a:off x="868680" y="2121408"/>
+            <a:off x="868680" y="2084832"/>
             <a:ext cx="2331720" cy="274320"/>
           </a:xfrm>
           <a:prstGeom prst="rect">
@@ -8637,7 +8637,7 @@
         </p:nvSpPr>
         <p:spPr>
           <a:xfrm>
-            <a:off x="868680" y="2395728"/>
+            <a:off x="868680" y="2350008"/>
             <a:ext cx="2331720" cy="228600"/>
           </a:xfrm>
           <a:prstGeom prst="rect">
@@ -8659,7 +8659,7 @@
                 </a:solidFill>
                 <a:latin typeface="Calibri"/>
               </a:rPr>
-              <a:t>read-only · never writes self-state</a:t>
+              <a:t>read-only · two-tier context</a:t>
             </a:r>
           </a:p>
         </p:txBody>
@@ -8672,8 +8672,8 @@
         </p:nvSpPr>
         <p:spPr>
           <a:xfrm>
-            <a:off x="868680" y="2779776"/>
-            <a:ext cx="2331720" cy="548640"/>
+            <a:off x="868680" y="2688336"/>
+            <a:ext cx="2331720" cy="512064"/>
           </a:xfrm>
           <a:prstGeom prst="roundRect">
             <a:avLst>
@@ -8720,8 +8720,8 @@
         </p:nvSpPr>
         <p:spPr>
           <a:xfrm>
-            <a:off x="1014983" y="2862072"/>
-            <a:ext cx="2057400" cy="228600"/>
+            <a:off x="1014983" y="2761488"/>
+            <a:ext cx="2057400" cy="219456"/>
           </a:xfrm>
           <a:prstGeom prst="rect">
             <a:avLst/>
@@ -8755,8 +8755,8 @@
         </p:nvSpPr>
         <p:spPr>
           <a:xfrm>
-            <a:off x="1014983" y="3081528"/>
-            <a:ext cx="2057400" cy="201168"/>
+            <a:off x="1014983" y="2971800"/>
+            <a:ext cx="2057400" cy="182880"/>
           </a:xfrm>
           <a:prstGeom prst="rect">
             <a:avLst/>
@@ -8771,150 +8771,32 @@
           <a:p>
             <a:pPr algn="l"/>
             <a:r>
-              <a:rPr sz="950" b="0" i="0">
+              <a:rPr sz="900" b="0" i="0">
                 <a:solidFill>
                   <a:srgbClr val="93A7C6"/>
                 </a:solidFill>
                 <a:latin typeface="Calibri"/>
               </a:rPr>
-              <a:t>current turn</a:t>
-            </a:r>
-          </a:p>
-        </p:txBody>
-      </p:sp>
-      <p:sp>
-        <p:nvSpPr>
-          <p:cNvPr id="12" name="Rounded Rectangle 11"/>
-          <p:cNvSpPr/>
-          <p:nvPr/>
-        </p:nvSpPr>
-        <p:spPr>
-          <a:xfrm>
-            <a:off x="868680" y="3438144"/>
-            <a:ext cx="2331720" cy="548640"/>
-          </a:xfrm>
-          <a:prstGeom prst="roundRect">
-            <a:avLst>
-              <a:gd name="adj" fmla="val 12000"/>
-            </a:avLst>
-          </a:prstGeom>
-          <a:solidFill>
-            <a:srgbClr val="0A101D"/>
-          </a:solidFill>
-          <a:ln w="12700">
-            <a:solidFill>
-              <a:srgbClr val="26385C"/>
-            </a:solidFill>
-          </a:ln>
-          <a:effectLst/>
-        </p:spPr>
-        <p:style>
-          <a:lnRef idx="1">
-            <a:schemeClr val="accent1"/>
-          </a:lnRef>
-          <a:fillRef idx="3">
-            <a:schemeClr val="accent1"/>
-          </a:fillRef>
-          <a:effectRef idx="2">
-            <a:schemeClr val="accent1"/>
-          </a:effectRef>
-          <a:fontRef idx="minor">
-            <a:schemeClr val="lt1"/>
-          </a:fontRef>
-        </p:style>
-        <p:txBody>
-          <a:bodyPr rtlCol="0" anchor="ctr"/>
-          <a:lstStyle/>
-          <a:p>
-            <a:pPr algn="ctr"/>
-          </a:p>
-        </p:txBody>
-      </p:sp>
-      <p:sp>
-        <p:nvSpPr>
-          <p:cNvPr id="13" name="TextBox 12"/>
-          <p:cNvSpPr txBox="1"/>
-          <p:nvPr/>
-        </p:nvSpPr>
-        <p:spPr>
-          <a:xfrm>
-            <a:off x="1014983" y="3520439"/>
-            <a:ext cx="2057400" cy="228600"/>
-          </a:xfrm>
-          <a:prstGeom prst="rect">
-            <a:avLst/>
-          </a:prstGeom>
-          <a:noFill/>
-        </p:spPr>
-        <p:txBody>
-          <a:bodyPr wrap="square" anchor="t" lIns="0" rIns="0" tIns="0" bIns="0">
-            <a:spAutoFit/>
-          </a:bodyPr>
-          <a:lstStyle/>
-          <a:p>
-            <a:pPr algn="l"/>
-            <a:r>
-              <a:rPr sz="1150" b="1" i="0">
-                <a:solidFill>
-                  <a:srgbClr val="EAF0FA"/>
-                </a:solidFill>
-                <a:latin typeface="Calibri"/>
-              </a:rPr>
-              <a:t>Aged gestalt summaries</a:t>
-            </a:r>
-          </a:p>
-        </p:txBody>
-      </p:sp>
-      <p:sp>
-        <p:nvSpPr>
-          <p:cNvPr id="14" name="TextBox 13"/>
-          <p:cNvSpPr txBox="1"/>
-          <p:nvPr/>
-        </p:nvSpPr>
-        <p:spPr>
-          <a:xfrm>
-            <a:off x="1014983" y="3739896"/>
-            <a:ext cx="2057400" cy="201168"/>
-          </a:xfrm>
-          <a:prstGeom prst="rect">
-            <a:avLst/>
-          </a:prstGeom>
-          <a:noFill/>
-        </p:spPr>
-        <p:txBody>
-          <a:bodyPr wrap="square" anchor="t" lIns="0" rIns="0" tIns="0" bIns="0">
-            <a:spAutoFit/>
-          </a:bodyPr>
-          <a:lstStyle/>
-          <a:p>
-            <a:pPr algn="l"/>
-            <a:r>
-              <a:rPr sz="950" b="0" i="0">
-                <a:solidFill>
-                  <a:srgbClr val="93A7C6"/>
-                </a:solidFill>
-                <a:latin typeface="Calibri"/>
-              </a:rPr>
-              <a:t>prior turns</a:t>
+              <a:t>current turn · full fidelity</a:t>
             </a:r>
           </a:p>
         </p:txBody>
       </p:sp>
       <p:cxnSp>
         <p:nvCxnSpPr>
-          <p:cNvPr id="15" name="Connector 14"/>
+          <p:cNvPr id="12" name="Connector 11"/>
           <p:cNvCxnSpPr/>
           <p:nvPr/>
         </p:nvCxnSpPr>
         <p:spPr>
           <a:xfrm>
-            <a:off x="2034539" y="4133087"/>
-            <a:ext cx="0" cy="237745"/>
+            <a:off x="2034539" y="3218688"/>
+            <a:ext cx="0" cy="164592"/>
           </a:xfrm>
           <a:prstGeom prst="bentConnector3">
             <a:avLst/>
           </a:prstGeom>
-          <a:ln w="17780">
+          <a:ln w="16510">
             <a:solidFill>
               <a:srgbClr val="5B9DF9"/>
             </a:solidFill>
@@ -8938,13 +8820,13 @@
       </p:cxnSp>
       <p:sp>
         <p:nvSpPr>
-          <p:cNvPr id="16" name="Isosceles Triangle 15"/>
+          <p:cNvPr id="13" name="Isosceles Triangle 12"/>
           <p:cNvSpPr/>
           <p:nvPr/>
         </p:nvSpPr>
         <p:spPr>
           <a:xfrm rot="10800000">
-            <a:off x="1965959" y="4302252"/>
+            <a:off x="1965959" y="3314700"/>
             <a:ext cx="137160" cy="137160"/>
           </a:xfrm>
           <a:prstGeom prst="triangle">
@@ -8982,14 +8864,14 @@
       </p:sp>
       <p:sp>
         <p:nvSpPr>
-          <p:cNvPr id="17" name="Rounded Rectangle 16"/>
+          <p:cNvPr id="14" name="Rounded Rectangle 13"/>
           <p:cNvSpPr/>
           <p:nvPr/>
         </p:nvSpPr>
         <p:spPr>
           <a:xfrm>
-            <a:off x="868680" y="4425696"/>
-            <a:ext cx="2331720" cy="566928"/>
+            <a:off x="868680" y="3419856"/>
+            <a:ext cx="2331720" cy="493776"/>
           </a:xfrm>
           <a:prstGeom prst="roundRect">
             <a:avLst>
@@ -9030,14 +8912,14 @@
       </p:sp>
       <p:sp>
         <p:nvSpPr>
-          <p:cNvPr id="18" name="TextBox 17"/>
-          <p:cNvSpPr txBox="1"/>
-          <p:nvPr/>
-        </p:nvSpPr>
-        <p:spPr>
-          <a:xfrm>
-            <a:off x="868680" y="4526280"/>
-            <a:ext cx="2331720" cy="228600"/>
+          <p:cNvPr id="15" name="TextBox 14"/>
+          <p:cNvSpPr txBox="1"/>
+          <p:nvPr/>
+        </p:nvSpPr>
+        <p:spPr>
+          <a:xfrm>
+            <a:off x="868680" y="3483864"/>
+            <a:ext cx="2331720" cy="219456"/>
           </a:xfrm>
           <a:prstGeom prst="rect">
             <a:avLst/>
@@ -9052,27 +8934,181 @@
           <a:p>
             <a:pPr algn="ctr"/>
             <a:r>
+              <a:rPr sz="1100" b="1" i="0">
+                <a:solidFill>
+                  <a:srgbClr val="5B9DF9"/>
+                </a:solidFill>
+                <a:latin typeface="Calibri"/>
+              </a:rPr>
+              <a:t>Input-lane encoder</a:t>
+            </a:r>
+          </a:p>
+        </p:txBody>
+      </p:sp>
+      <p:sp>
+        <p:nvSpPr>
+          <p:cNvPr id="16" name="TextBox 15"/>
+          <p:cNvSpPr txBox="1"/>
+          <p:nvPr/>
+        </p:nvSpPr>
+        <p:spPr>
+          <a:xfrm>
+            <a:off x="868680" y="3685032"/>
+            <a:ext cx="2331720" cy="182880"/>
+          </a:xfrm>
+          <a:prstGeom prst="rect">
+            <a:avLst/>
+          </a:prstGeom>
+          <a:noFill/>
+        </p:spPr>
+        <p:txBody>
+          <a:bodyPr wrap="square" anchor="t" lIns="0" rIns="0" tIns="0" bIns="0">
+            <a:spAutoFit/>
+          </a:bodyPr>
+          <a:lstStyle/>
+          <a:p>
+            <a:pPr algn="ctr"/>
+            <a:r>
+              <a:rPr sz="900" b="0" i="0">
+                <a:solidFill>
+                  <a:srgbClr val="93A7C6"/>
+                </a:solidFill>
+                <a:latin typeface="Calibri"/>
+              </a:rPr>
+              <a:t>bidirectional</a:t>
+            </a:r>
+          </a:p>
+        </p:txBody>
+      </p:sp>
+      <p:cxnSp>
+        <p:nvCxnSpPr>
+          <p:cNvPr id="17" name="Connector 16"/>
+          <p:cNvCxnSpPr/>
+          <p:nvPr/>
+        </p:nvCxnSpPr>
+        <p:spPr>
+          <a:xfrm>
+            <a:off x="868680" y="4078224"/>
+            <a:ext cx="2331720" cy="0"/>
+          </a:xfrm>
+          <a:prstGeom prst="bentConnector3">
+            <a:avLst/>
+          </a:prstGeom>
+          <a:ln w="12700">
+            <a:solidFill>
+              <a:srgbClr val="26385C"/>
+            </a:solidFill>
+          </a:ln>
+          <a:effectLst/>
+        </p:spPr>
+        <p:style>
+          <a:lnRef idx="2">
+            <a:schemeClr val="accent1"/>
+          </a:lnRef>
+          <a:fillRef idx="0">
+            <a:schemeClr val="accent1"/>
+          </a:fillRef>
+          <a:effectRef idx="1">
+            <a:schemeClr val="accent1"/>
+          </a:effectRef>
+          <a:fontRef idx="minor">
+            <a:schemeClr val="tx1"/>
+          </a:fontRef>
+        </p:style>
+      </p:cxnSp>
+      <p:sp>
+        <p:nvSpPr>
+          <p:cNvPr id="18" name="Rounded Rectangle 17"/>
+          <p:cNvSpPr/>
+          <p:nvPr/>
+        </p:nvSpPr>
+        <p:spPr>
+          <a:xfrm>
+            <a:off x="868680" y="4206240"/>
+            <a:ext cx="2331720" cy="512064"/>
+          </a:xfrm>
+          <a:prstGeom prst="roundRect">
+            <a:avLst>
+              <a:gd name="adj" fmla="val 12000"/>
+            </a:avLst>
+          </a:prstGeom>
+          <a:solidFill>
+            <a:srgbClr val="0A101D"/>
+          </a:solidFill>
+          <a:ln w="12700">
+            <a:solidFill>
+              <a:srgbClr val="5B9DF9"/>
+            </a:solidFill>
+          </a:ln>
+          <a:effectLst/>
+        </p:spPr>
+        <p:style>
+          <a:lnRef idx="1">
+            <a:schemeClr val="accent1"/>
+          </a:lnRef>
+          <a:fillRef idx="3">
+            <a:schemeClr val="accent1"/>
+          </a:fillRef>
+          <a:effectRef idx="2">
+            <a:schemeClr val="accent1"/>
+          </a:effectRef>
+          <a:fontRef idx="minor">
+            <a:schemeClr val="lt1"/>
+          </a:fontRef>
+        </p:style>
+        <p:txBody>
+          <a:bodyPr rtlCol="0" anchor="ctr"/>
+          <a:lstStyle/>
+          <a:p>
+            <a:pPr algn="ctr"/>
+          </a:p>
+        </p:txBody>
+      </p:sp>
+      <p:sp>
+        <p:nvSpPr>
+          <p:cNvPr id="19" name="TextBox 18"/>
+          <p:cNvSpPr txBox="1"/>
+          <p:nvPr/>
+        </p:nvSpPr>
+        <p:spPr>
+          <a:xfrm>
+            <a:off x="1014983" y="4279392"/>
+            <a:ext cx="2057400" cy="219456"/>
+          </a:xfrm>
+          <a:prstGeom prst="rect">
+            <a:avLst/>
+          </a:prstGeom>
+          <a:noFill/>
+        </p:spPr>
+        <p:txBody>
+          <a:bodyPr wrap="square" anchor="t" lIns="0" rIns="0" tIns="0" bIns="0">
+            <a:spAutoFit/>
+          </a:bodyPr>
+          <a:lstStyle/>
+          <a:p>
+            <a:pPr algn="l"/>
+            <a:r>
               <a:rPr sz="1150" b="1" i="0">
                 <a:solidFill>
-                  <a:srgbClr val="5B9DF9"/>
-                </a:solidFill>
-                <a:latin typeface="Calibri"/>
-              </a:rPr>
-              <a:t>Input-lane encoder</a:t>
-            </a:r>
-          </a:p>
-        </p:txBody>
-      </p:sp>
-      <p:sp>
-        <p:nvSpPr>
-          <p:cNvPr id="19" name="TextBox 18"/>
-          <p:cNvSpPr txBox="1"/>
-          <p:nvPr/>
-        </p:nvSpPr>
-        <p:spPr>
-          <a:xfrm>
-            <a:off x="868680" y="4736592"/>
-            <a:ext cx="2331720" cy="201168"/>
+                  <a:srgbClr val="EAF0FA"/>
+                </a:solidFill>
+                <a:latin typeface="Calibri"/>
+              </a:rPr>
+              <a:t>Aged gestalts</a:t>
+            </a:r>
+          </a:p>
+        </p:txBody>
+      </p:sp>
+      <p:sp>
+        <p:nvSpPr>
+          <p:cNvPr id="20" name="TextBox 19"/>
+          <p:cNvSpPr txBox="1"/>
+          <p:nvPr/>
+        </p:nvSpPr>
+        <p:spPr>
+          <a:xfrm>
+            <a:off x="1014983" y="4489704"/>
+            <a:ext cx="2057400" cy="182880"/>
           </a:xfrm>
           <a:prstGeom prst="rect">
             <a:avLst/>
@@ -9085,29 +9121,29 @@
           </a:bodyPr>
           <a:lstStyle/>
           <a:p>
-            <a:pPr algn="ctr"/>
-            <a:r>
-              <a:rPr sz="950" b="0" i="0">
+            <a:pPr algn="l"/>
+            <a:r>
+              <a:rPr sz="900" b="0" i="0">
                 <a:solidFill>
                   <a:srgbClr val="93A7C6"/>
                 </a:solidFill>
                 <a:latin typeface="Calibri"/>
               </a:rPr>
-              <a:t>bidirectional</a:t>
-            </a:r>
-          </a:p>
-        </p:txBody>
-      </p:sp>
-      <p:sp>
-        <p:nvSpPr>
-          <p:cNvPr id="20" name="TextBox 19"/>
-          <p:cNvSpPr txBox="1"/>
-          <p:nvPr/>
-        </p:nvSpPr>
-        <p:spPr>
-          <a:xfrm>
-            <a:off x="868680" y="5138928"/>
-            <a:ext cx="2331720" cy="640080"/>
+              <a:t>prior turns · compressed</a:t>
+            </a:r>
+          </a:p>
+        </p:txBody>
+      </p:sp>
+      <p:sp>
+        <p:nvSpPr>
+          <p:cNvPr id="21" name="TextBox 20"/>
+          <p:cNvSpPr txBox="1"/>
+          <p:nvPr/>
+        </p:nvSpPr>
+        <p:spPr>
+          <a:xfrm>
+            <a:off x="868680" y="4791456"/>
+            <a:ext cx="2331720" cy="457200"/>
           </a:xfrm>
           <a:prstGeom prst="rect">
             <a:avLst/>
@@ -9122,55 +9158,81 @@
           <a:p>
             <a:pPr algn="l">
               <a:lnSpc>
-                <a:spcPct val="116000"/>
+                <a:spcPct val="112000"/>
               </a:lnSpc>
-              <a:spcAft>
-                <a:spcPts val="300"/>
-              </a:spcAft>
             </a:pPr>
             <a:r>
-              <a:rPr sz="1000" b="0" i="0">
-                <a:solidFill>
-                  <a:srgbClr val="93A7C6"/>
-                </a:solidFill>
-                <a:latin typeface="Calibri"/>
-              </a:rPr>
-              <a:t>Role tags  </a:t>
-            </a:r>
-            <a:r>
-              <a:rPr sz="1000" b="1" i="0">
-                <a:solidFill>
-                  <a:srgbClr val="EAF0FA"/>
-                </a:solidFill>
-                <a:latin typeface="Calibri"/>
-              </a:rPr>
-              <a:t>USER · SELF · SYSTEM</a:t>
-            </a:r>
-          </a:p>
+              <a:rPr sz="850" b="0" i="1">
+                <a:solidFill>
+                  <a:srgbClr val="63769A"/>
+                </a:solidFill>
+                <a:latin typeface="Calibri"/>
+              </a:rPr>
+              <a:t>The same gestalt memory's USER/SYSTEM slots, recalled — not a second store.</a:t>
+            </a:r>
+          </a:p>
+        </p:txBody>
+      </p:sp>
+      <p:sp>
+        <p:nvSpPr>
+          <p:cNvPr id="22" name="TextBox 21"/>
+          <p:cNvSpPr txBox="1"/>
+          <p:nvPr/>
+        </p:nvSpPr>
+        <p:spPr>
+          <a:xfrm>
+            <a:off x="868680" y="5358384"/>
+            <a:ext cx="2331720" cy="365760"/>
+          </a:xfrm>
+          <a:prstGeom prst="rect">
+            <a:avLst/>
+          </a:prstGeom>
+          <a:noFill/>
+        </p:spPr>
+        <p:txBody>
+          <a:bodyPr wrap="square" anchor="t" lIns="0" rIns="0" tIns="0" bIns="0">
+            <a:spAutoFit/>
+          </a:bodyPr>
+          <a:lstStyle/>
           <a:p>
             <a:pPr algn="l">
               <a:lnSpc>
-                <a:spcPct val="116000"/>
+                <a:spcPct val="114000"/>
               </a:lnSpc>
-              <a:spcAft>
-                <a:spcPts val="300"/>
-              </a:spcAft>
             </a:pPr>
             <a:r>
-              <a:rPr sz="950" b="0" i="1">
-                <a:solidFill>
-                  <a:srgbClr val="63769A"/>
-                </a:solidFill>
-                <a:latin typeface="Calibri"/>
-              </a:rPr>
-              <a:t>The loop only cross-attends to it — the substrate for a self / input boundary.</a:t>
-            </a:r>
-          </a:p>
-        </p:txBody>
-      </p:sp>
-      <p:sp>
-        <p:nvSpPr>
-          <p:cNvPr id="21" name="Rounded Rectangle 20"/>
+              <a:rPr sz="900" b="0" i="0">
+                <a:solidFill>
+                  <a:srgbClr val="93A7C6"/>
+                </a:solidFill>
+                <a:latin typeface="Calibri"/>
+              </a:rPr>
+              <a:t>Role tags </a:t>
+            </a:r>
+            <a:r>
+              <a:rPr sz="900" b="1" i="0">
+                <a:solidFill>
+                  <a:srgbClr val="EAF0FA"/>
+                </a:solidFill>
+                <a:latin typeface="Calibri"/>
+              </a:rPr>
+              <a:t>USER·SELF·SYSTEM</a:t>
+            </a:r>
+            <a:r>
+              <a:rPr sz="900" b="0" i="0">
+                <a:solidFill>
+                  <a:srgbClr val="93A7C6"/>
+                </a:solidFill>
+                <a:latin typeface="Calibri"/>
+              </a:rPr>
+              <a:t> · never writes self-state</a:t>
+            </a:r>
+          </a:p>
+        </p:txBody>
+      </p:sp>
+      <p:sp>
+        <p:nvSpPr>
+          <p:cNvPr id="23" name="Rounded Rectangle 22"/>
           <p:cNvSpPr/>
           <p:nvPr/>
         </p:nvSpPr>
@@ -9225,22 +9287,22 @@
       </p:sp>
       <p:sp>
         <p:nvSpPr>
-          <p:cNvPr id="22" name="TextBox 21"/>
-          <p:cNvSpPr txBox="1"/>
-          <p:nvPr/>
-        </p:nvSpPr>
-        <p:spPr>
-          <a:xfrm>
-            <a:off x="5074920" y="1938528"/>
-            <a:ext cx="6355080" cy="548640"/>
-          </a:xfrm>
-          <a:prstGeom prst="rect">
-            <a:avLst/>
-          </a:prstGeom>
-          <a:noFill/>
-        </p:spPr>
-        <p:txBody>
-          <a:bodyPr wrap="square" anchor="ctr" lIns="0" rIns="0" tIns="0" bIns="0">
+          <p:cNvPr id="24" name="TextBox 23"/>
+          <p:cNvSpPr txBox="1"/>
+          <p:nvPr/>
+        </p:nvSpPr>
+        <p:spPr>
+          <a:xfrm>
+            <a:off x="5074920" y="2020824"/>
+            <a:ext cx="6355080" cy="237744"/>
+          </a:xfrm>
+          <a:prstGeom prst="rect">
+            <a:avLst/>
+          </a:prstGeom>
+          <a:noFill/>
+        </p:spPr>
+        <p:txBody>
+          <a:bodyPr wrap="square" anchor="t" lIns="0" rIns="0" tIns="0" bIns="0">
             <a:spAutoFit/>
           </a:bodyPr>
           <a:lstStyle/>
@@ -9255,28 +9317,54 @@
               </a:rPr>
               <a:t>CHUNK ENCODER</a:t>
             </a:r>
-            <a:r>
-              <a:rPr sz="1050" b="0" i="0">
+          </a:p>
+        </p:txBody>
+      </p:sp>
+      <p:sp>
+        <p:nvSpPr>
+          <p:cNvPr id="25" name="TextBox 24"/>
+          <p:cNvSpPr txBox="1"/>
+          <p:nvPr/>
+        </p:nvSpPr>
+        <p:spPr>
+          <a:xfrm>
+            <a:off x="5074920" y="2249424"/>
+            <a:ext cx="6355080" cy="201168"/>
+          </a:xfrm>
+          <a:prstGeom prst="rect">
+            <a:avLst/>
+          </a:prstGeom>
+          <a:noFill/>
+        </p:spPr>
+        <p:txBody>
+          <a:bodyPr wrap="square" anchor="t" lIns="0" rIns="0" tIns="0" bIns="0">
+            <a:spAutoFit/>
+          </a:bodyPr>
+          <a:lstStyle/>
+          <a:p>
+            <a:pPr algn="ctr"/>
+            <a:r>
+              <a:rPr sz="950" b="0" i="0">
                 <a:solidFill>
                   <a:srgbClr val="93A7C6"/>
                 </a:solidFill>
                 <a:latin typeface="Calibri"/>
               </a:rPr>
-              <a:t>     chunk cₜ  →  192-d thought latent</a:t>
+              <a:t>SaT-Capped chunker  →  chunk cₜ  →  192-d thought latent</a:t>
             </a:r>
           </a:p>
         </p:txBody>
       </p:sp>
       <p:cxnSp>
         <p:nvCxnSpPr>
-          <p:cNvPr id="23" name="Connector 22"/>
+          <p:cNvPr id="26" name="Connector 25"/>
           <p:cNvCxnSpPr/>
           <p:nvPr/>
         </p:nvCxnSpPr>
         <p:spPr>
           <a:xfrm>
             <a:off x="8252460" y="2487168"/>
-            <a:ext cx="0" cy="256032"/>
+            <a:ext cx="0" cy="237744"/>
           </a:xfrm>
           <a:prstGeom prst="bentConnector3">
             <a:avLst/>
@@ -9305,13 +9393,13 @@
       </p:cxnSp>
       <p:sp>
         <p:nvSpPr>
-          <p:cNvPr id="24" name="Isosceles Triangle 23"/>
+          <p:cNvPr id="27" name="Isosceles Triangle 26"/>
           <p:cNvSpPr/>
           <p:nvPr/>
         </p:nvSpPr>
         <p:spPr>
           <a:xfrm rot="10800000">
-            <a:off x="8183880" y="2674620"/>
+            <a:off x="8183880" y="2656332"/>
             <a:ext cx="137160" cy="137160"/>
           </a:xfrm>
           <a:prstGeom prst="triangle">
@@ -9349,13 +9437,13 @@
       </p:sp>
       <p:sp>
         <p:nvSpPr>
-          <p:cNvPr id="25" name="Rounded Rectangle 24"/>
+          <p:cNvPr id="28" name="Rounded Rectangle 27"/>
           <p:cNvSpPr/>
           <p:nvPr/>
         </p:nvSpPr>
         <p:spPr>
           <a:xfrm>
-            <a:off x="5074920" y="2761488"/>
+            <a:off x="5074920" y="2743200"/>
             <a:ext cx="6355080" cy="1097280"/>
           </a:xfrm>
           <a:prstGeom prst="roundRect">
@@ -9404,13 +9492,13 @@
       </p:sp>
       <p:sp>
         <p:nvSpPr>
-          <p:cNvPr id="26" name="TextBox 25"/>
-          <p:cNvSpPr txBox="1"/>
-          <p:nvPr/>
-        </p:nvSpPr>
-        <p:spPr>
-          <a:xfrm>
-            <a:off x="5074920" y="2880360"/>
+          <p:cNvPr id="29" name="TextBox 28"/>
+          <p:cNvSpPr txBox="1"/>
+          <p:nvPr/>
+        </p:nvSpPr>
+        <p:spPr>
+          <a:xfrm>
+            <a:off x="5074920" y="2862072"/>
             <a:ext cx="6355080" cy="256032"/>
           </a:xfrm>
           <a:prstGeom prst="rect">
@@ -9439,13 +9527,13 @@
       </p:sp>
       <p:sp>
         <p:nvSpPr>
-          <p:cNvPr id="27" name="Rounded Rectangle 26"/>
+          <p:cNvPr id="30" name="Rounded Rectangle 29"/>
           <p:cNvSpPr/>
           <p:nvPr/>
         </p:nvSpPr>
         <p:spPr>
           <a:xfrm>
-            <a:off x="7283196" y="3218688"/>
+            <a:off x="7283196" y="3200400"/>
             <a:ext cx="384048" cy="347472"/>
           </a:xfrm>
           <a:prstGeom prst="roundRect">
@@ -9487,13 +9575,13 @@
       </p:sp>
       <p:sp>
         <p:nvSpPr>
-          <p:cNvPr id="28" name="TextBox 27"/>
-          <p:cNvSpPr txBox="1"/>
-          <p:nvPr/>
-        </p:nvSpPr>
-        <p:spPr>
-          <a:xfrm>
-            <a:off x="7283196" y="3218688"/>
+          <p:cNvPr id="31" name="TextBox 30"/>
+          <p:cNvSpPr txBox="1"/>
+          <p:nvPr/>
+        </p:nvSpPr>
+        <p:spPr>
+          <a:xfrm>
+            <a:off x="7283196" y="3200400"/>
             <a:ext cx="384048" cy="347472"/>
           </a:xfrm>
           <a:prstGeom prst="rect">
@@ -9522,13 +9610,13 @@
       </p:sp>
       <p:sp>
         <p:nvSpPr>
-          <p:cNvPr id="29" name="Rounded Rectangle 28"/>
+          <p:cNvPr id="32" name="Rounded Rectangle 31"/>
           <p:cNvSpPr/>
           <p:nvPr/>
         </p:nvSpPr>
         <p:spPr>
           <a:xfrm>
-            <a:off x="7740396" y="3218688"/>
+            <a:off x="7740396" y="3200400"/>
             <a:ext cx="384048" cy="347472"/>
           </a:xfrm>
           <a:prstGeom prst="roundRect">
@@ -9570,13 +9658,13 @@
       </p:sp>
       <p:sp>
         <p:nvSpPr>
-          <p:cNvPr id="30" name="TextBox 29"/>
-          <p:cNvSpPr txBox="1"/>
-          <p:nvPr/>
-        </p:nvSpPr>
-        <p:spPr>
-          <a:xfrm>
-            <a:off x="7740396" y="3218688"/>
+          <p:cNvPr id="33" name="TextBox 32"/>
+          <p:cNvSpPr txBox="1"/>
+          <p:nvPr/>
+        </p:nvSpPr>
+        <p:spPr>
+          <a:xfrm>
+            <a:off x="7740396" y="3200400"/>
             <a:ext cx="384048" cy="347472"/>
           </a:xfrm>
           <a:prstGeom prst="rect">
@@ -9605,13 +9693,13 @@
       </p:sp>
       <p:sp>
         <p:nvSpPr>
-          <p:cNvPr id="31" name="Rounded Rectangle 30"/>
+          <p:cNvPr id="34" name="Rounded Rectangle 33"/>
           <p:cNvSpPr/>
           <p:nvPr/>
         </p:nvSpPr>
         <p:spPr>
           <a:xfrm>
-            <a:off x="8197596" y="3218688"/>
+            <a:off x="8197596" y="3200400"/>
             <a:ext cx="384048" cy="347472"/>
           </a:xfrm>
           <a:prstGeom prst="roundRect">
@@ -9653,13 +9741,13 @@
       </p:sp>
       <p:sp>
         <p:nvSpPr>
-          <p:cNvPr id="32" name="TextBox 31"/>
-          <p:cNvSpPr txBox="1"/>
-          <p:nvPr/>
-        </p:nvSpPr>
-        <p:spPr>
-          <a:xfrm>
-            <a:off x="8197596" y="3218688"/>
+          <p:cNvPr id="35" name="TextBox 34"/>
+          <p:cNvSpPr txBox="1"/>
+          <p:nvPr/>
+        </p:nvSpPr>
+        <p:spPr>
+          <a:xfrm>
+            <a:off x="8197596" y="3200400"/>
             <a:ext cx="384048" cy="347472"/>
           </a:xfrm>
           <a:prstGeom prst="rect">
@@ -9688,13 +9776,13 @@
       </p:sp>
       <p:sp>
         <p:nvSpPr>
-          <p:cNvPr id="33" name="Rounded Rectangle 32"/>
+          <p:cNvPr id="36" name="Rounded Rectangle 35"/>
           <p:cNvSpPr/>
           <p:nvPr/>
         </p:nvSpPr>
         <p:spPr>
           <a:xfrm>
-            <a:off x="8764524" y="3218688"/>
+            <a:off x="8764524" y="3200400"/>
             <a:ext cx="457200" cy="347472"/>
           </a:xfrm>
           <a:prstGeom prst="roundRect">
@@ -9736,13 +9824,13 @@
       </p:sp>
       <p:sp>
         <p:nvSpPr>
-          <p:cNvPr id="34" name="TextBox 33"/>
-          <p:cNvSpPr txBox="1"/>
-          <p:nvPr/>
-        </p:nvSpPr>
-        <p:spPr>
-          <a:xfrm>
-            <a:off x="8764524" y="3218688"/>
+          <p:cNvPr id="37" name="TextBox 36"/>
+          <p:cNvSpPr txBox="1"/>
+          <p:nvPr/>
+        </p:nvSpPr>
+        <p:spPr>
+          <a:xfrm>
+            <a:off x="8764524" y="3200400"/>
             <a:ext cx="457200" cy="347472"/>
           </a:xfrm>
           <a:prstGeom prst="rect">
@@ -9771,13 +9859,13 @@
       </p:sp>
       <p:sp>
         <p:nvSpPr>
-          <p:cNvPr id="35" name="TextBox 34"/>
-          <p:cNvSpPr txBox="1"/>
-          <p:nvPr/>
-        </p:nvSpPr>
-        <p:spPr>
-          <a:xfrm>
-            <a:off x="5074920" y="3630168"/>
+          <p:cNvPr id="38" name="TextBox 37"/>
+          <p:cNvSpPr txBox="1"/>
+          <p:nvPr/>
+        </p:nvSpPr>
+        <p:spPr>
+          <a:xfrm>
+            <a:off x="5074920" y="3611880"/>
             <a:ext cx="6355080" cy="219456"/>
           </a:xfrm>
           <a:prstGeom prst="rect">
@@ -9806,14 +9894,14 @@
       </p:sp>
       <p:cxnSp>
         <p:nvCxnSpPr>
-          <p:cNvPr id="36" name="Connector 35"/>
+          <p:cNvPr id="39" name="Connector 38"/>
           <p:cNvCxnSpPr/>
           <p:nvPr/>
         </p:nvCxnSpPr>
         <p:spPr>
           <a:xfrm>
-            <a:off x="8252460" y="3858768"/>
-            <a:ext cx="0" cy="256032"/>
+            <a:off x="8252460" y="3840480"/>
+            <a:ext cx="0" cy="237744"/>
           </a:xfrm>
           <a:prstGeom prst="bentConnector3">
             <a:avLst/>
@@ -9842,13 +9930,13 @@
       </p:cxnSp>
       <p:sp>
         <p:nvSpPr>
-          <p:cNvPr id="37" name="Isosceles Triangle 36"/>
+          <p:cNvPr id="40" name="Isosceles Triangle 39"/>
           <p:cNvSpPr/>
           <p:nvPr/>
         </p:nvSpPr>
         <p:spPr>
           <a:xfrm rot="10800000">
-            <a:off x="8183880" y="4046220"/>
+            <a:off x="8183880" y="4009644"/>
             <a:ext cx="137160" cy="137160"/>
           </a:xfrm>
           <a:prstGeom prst="triangle">
@@ -9886,13 +9974,13 @@
       </p:sp>
       <p:sp>
         <p:nvSpPr>
-          <p:cNvPr id="38" name="TextBox 37"/>
-          <p:cNvSpPr txBox="1"/>
-          <p:nvPr/>
-        </p:nvSpPr>
-        <p:spPr>
-          <a:xfrm>
-            <a:off x="8389620" y="3867911"/>
+          <p:cNvPr id="41" name="TextBox 40"/>
+          <p:cNvSpPr txBox="1"/>
+          <p:nvPr/>
+        </p:nvSpPr>
+        <p:spPr>
+          <a:xfrm>
+            <a:off x="8389620" y="3822192"/>
             <a:ext cx="2011680" cy="237744"/>
           </a:xfrm>
           <a:prstGeom prst="rect">
@@ -9914,21 +10002,21 @@
                 </a:solidFill>
                 <a:latin typeface="Calibri"/>
               </a:rPr>
-              <a:t>write thought zₜ</a:t>
-            </a:r>
-          </a:p>
-        </p:txBody>
-      </p:sp>
-      <p:sp>
-        <p:nvSpPr>
-          <p:cNvPr id="39" name="Rounded Rectangle 38"/>
+              <a:t>write thought zₜ (SELF)</a:t>
+            </a:r>
+          </a:p>
+        </p:txBody>
+      </p:sp>
+      <p:sp>
+        <p:nvSpPr>
+          <p:cNvPr id="42" name="Rounded Rectangle 41"/>
           <p:cNvSpPr/>
           <p:nvPr/>
         </p:nvSpPr>
         <p:spPr>
           <a:xfrm>
-            <a:off x="5074920" y="4114800"/>
-            <a:ext cx="6355080" cy="676656"/>
+            <a:off x="5074920" y="4078224"/>
+            <a:ext cx="6355080" cy="841248"/>
           </a:xfrm>
           <a:prstGeom prst="roundRect">
             <a:avLst>
@@ -9938,7 +10026,7 @@
           <a:solidFill>
             <a:srgbClr val="1B2C4A"/>
           </a:solidFill>
-          <a:ln w="16510">
+          <a:ln w="17780">
             <a:solidFill>
               <a:srgbClr val="5B9DF9"/>
             </a:solidFill>
@@ -9976,14 +10064,14 @@
       </p:sp>
       <p:sp>
         <p:nvSpPr>
-          <p:cNvPr id="40" name="TextBox 39"/>
-          <p:cNvSpPr txBox="1"/>
-          <p:nvPr/>
-        </p:nvSpPr>
-        <p:spPr>
-          <a:xfrm>
-            <a:off x="5349240" y="4242816"/>
-            <a:ext cx="4160520" cy="256032"/>
+          <p:cNvPr id="43" name="TextBox 42"/>
+          <p:cNvSpPr txBox="1"/>
+          <p:nvPr/>
+        </p:nvSpPr>
+        <p:spPr>
+          <a:xfrm>
+            <a:off x="5349240" y="4169663"/>
+            <a:ext cx="4206240" cy="237744"/>
           </a:xfrm>
           <a:prstGeom prst="rect">
             <a:avLst/>
@@ -10006,19 +10094,28 @@
               </a:rPr>
               <a:t>GESTALT MEMORY</a:t>
             </a:r>
-          </a:p>
-        </p:txBody>
-      </p:sp>
-      <p:sp>
-        <p:nvSpPr>
-          <p:cNvPr id="41" name="TextBox 40"/>
-          <p:cNvSpPr txBox="1"/>
-          <p:nvPr/>
-        </p:nvSpPr>
-        <p:spPr>
-          <a:xfrm>
-            <a:off x="5349240" y="4498848"/>
-            <a:ext cx="4160520" cy="219456"/>
+            <a:r>
+              <a:rPr sz="1000" b="0" i="1">
+                <a:solidFill>
+                  <a:srgbClr val="93A7C6"/>
+                </a:solidFill>
+                <a:latin typeface="Calibri"/>
+              </a:rPr>
+              <a:t>   — one store</a:t>
+            </a:r>
+          </a:p>
+        </p:txBody>
+      </p:sp>
+      <p:sp>
+        <p:nvSpPr>
+          <p:cNvPr id="44" name="TextBox 43"/>
+          <p:cNvSpPr txBox="1"/>
+          <p:nvPr/>
+        </p:nvSpPr>
+        <p:spPr>
+          <a:xfrm>
+            <a:off x="5349240" y="4416552"/>
+            <a:ext cx="4206240" cy="201168"/>
           </a:xfrm>
           <a:prstGeom prst="rect">
             <a:avLst/>
@@ -10033,27 +10130,89 @@
           <a:p>
             <a:pPr algn="l"/>
             <a:r>
-              <a:rPr sz="1000" b="0" i="0">
+              <a:rPr sz="950" b="0" i="0">
                 <a:solidFill>
                   <a:srgbClr val="93A7C6"/>
                 </a:solidFill>
                 <a:latin typeface="Calibri"/>
               </a:rPr>
-              <a:t>FIFO · role-tagged · ungated gradient · next thought recalls it at O(1)</a:t>
-            </a:r>
-          </a:p>
-        </p:txBody>
-      </p:sp>
-      <p:sp>
-        <p:nvSpPr>
-          <p:cNvPr id="42" name="Rounded Rectangle 41"/>
+              <a:t>FIFO · role-tagged · ungated gradient · O(1) recall</a:t>
+            </a:r>
+          </a:p>
+        </p:txBody>
+      </p:sp>
+      <p:sp>
+        <p:nvSpPr>
+          <p:cNvPr id="45" name="TextBox 44"/>
+          <p:cNvSpPr txBox="1"/>
+          <p:nvPr/>
+        </p:nvSpPr>
+        <p:spPr>
+          <a:xfrm>
+            <a:off x="5349240" y="4645152"/>
+            <a:ext cx="4206240" cy="219456"/>
+          </a:xfrm>
+          <a:prstGeom prst="rect">
+            <a:avLst/>
+          </a:prstGeom>
+          <a:noFill/>
+        </p:spPr>
+        <p:txBody>
+          <a:bodyPr wrap="square" anchor="t" lIns="0" rIns="0" tIns="0" bIns="0">
+            <a:spAutoFit/>
+          </a:bodyPr>
+          <a:lstStyle/>
+          <a:p>
+            <a:pPr algn="l"/>
+            <a:r>
+              <a:rPr sz="950" b="1" i="0">
+                <a:solidFill>
+                  <a:srgbClr val="2DD4BF"/>
+                </a:solidFill>
+                <a:latin typeface="Calibri"/>
+              </a:rPr>
+              <a:t>SELF</a:t>
+            </a:r>
+            <a:r>
+              <a:rPr sz="950" b="0" i="0">
+                <a:solidFill>
+                  <a:srgbClr val="93A7C6"/>
+                </a:solidFill>
+                <a:latin typeface="Calibri"/>
+              </a:rPr>
+              <a:t> = this loop's thoughts     </a:t>
+            </a:r>
+            <a:r>
+              <a:rPr sz="950" b="1" i="0">
+                <a:solidFill>
+                  <a:srgbClr val="5B9DF9"/>
+                </a:solidFill>
+                <a:latin typeface="Calibri"/>
+              </a:rPr>
+              <a:t>USER/SYSTEM</a:t>
+            </a:r>
+            <a:r>
+              <a:rPr sz="950" b="0" i="0">
+                <a:solidFill>
+                  <a:srgbClr val="93A7C6"/>
+                </a:solidFill>
+                <a:latin typeface="Calibri"/>
+              </a:rPr>
+              <a:t> = aged input</a:t>
+            </a:r>
+          </a:p>
+        </p:txBody>
+      </p:sp>
+      <p:sp>
+        <p:nvSpPr>
+          <p:cNvPr id="46" name="Rounded Rectangle 45"/>
           <p:cNvSpPr/>
           <p:nvPr/>
         </p:nvSpPr>
         <p:spPr>
           <a:xfrm>
-            <a:off x="9555480" y="4315968"/>
-            <a:ext cx="457200" cy="310896"/>
+            <a:off x="9582912" y="4361688"/>
+            <a:ext cx="438912" cy="292608"/>
           </a:xfrm>
           <a:prstGeom prst="roundRect">
             <a:avLst>
@@ -10094,14 +10253,14 @@
       </p:sp>
       <p:sp>
         <p:nvSpPr>
-          <p:cNvPr id="43" name="TextBox 42"/>
-          <p:cNvSpPr txBox="1"/>
-          <p:nvPr/>
-        </p:nvSpPr>
-        <p:spPr>
-          <a:xfrm>
-            <a:off x="9555480" y="4315968"/>
-            <a:ext cx="457200" cy="310896"/>
+          <p:cNvPr id="47" name="TextBox 46"/>
+          <p:cNvSpPr txBox="1"/>
+          <p:nvPr/>
+        </p:nvSpPr>
+        <p:spPr>
+          <a:xfrm>
+            <a:off x="9582912" y="4361688"/>
+            <a:ext cx="438912" cy="292608"/>
           </a:xfrm>
           <a:prstGeom prst="rect">
             <a:avLst/>
@@ -10129,14 +10288,14 @@
       </p:sp>
       <p:sp>
         <p:nvSpPr>
-          <p:cNvPr id="44" name="Rounded Rectangle 43"/>
+          <p:cNvPr id="48" name="Rounded Rectangle 47"/>
           <p:cNvSpPr/>
           <p:nvPr/>
         </p:nvSpPr>
         <p:spPr>
           <a:xfrm>
-            <a:off x="10067544" y="4315968"/>
-            <a:ext cx="457200" cy="310896"/>
+            <a:off x="10076688" y="4361688"/>
+            <a:ext cx="438912" cy="292608"/>
           </a:xfrm>
           <a:prstGeom prst="roundRect">
             <a:avLst>
@@ -10177,14 +10336,14 @@
       </p:sp>
       <p:sp>
         <p:nvSpPr>
-          <p:cNvPr id="45" name="TextBox 44"/>
-          <p:cNvSpPr txBox="1"/>
-          <p:nvPr/>
-        </p:nvSpPr>
-        <p:spPr>
-          <a:xfrm>
-            <a:off x="10067544" y="4315968"/>
-            <a:ext cx="457200" cy="310896"/>
+          <p:cNvPr id="49" name="TextBox 48"/>
+          <p:cNvSpPr txBox="1"/>
+          <p:nvPr/>
+        </p:nvSpPr>
+        <p:spPr>
+          <a:xfrm>
+            <a:off x="10076688" y="4361688"/>
+            <a:ext cx="438912" cy="292608"/>
           </a:xfrm>
           <a:prstGeom prst="rect">
             <a:avLst/>
@@ -10212,14 +10371,14 @@
       </p:sp>
       <p:sp>
         <p:nvSpPr>
-          <p:cNvPr id="46" name="Rounded Rectangle 45"/>
+          <p:cNvPr id="50" name="Rounded Rectangle 49"/>
           <p:cNvSpPr/>
           <p:nvPr/>
         </p:nvSpPr>
         <p:spPr>
           <a:xfrm>
-            <a:off x="10579608" y="4315968"/>
-            <a:ext cx="457200" cy="310896"/>
+            <a:off x="10570463" y="4361688"/>
+            <a:ext cx="438912" cy="292608"/>
           </a:xfrm>
           <a:prstGeom prst="roundRect">
             <a:avLst>
@@ -10260,14 +10419,14 @@
       </p:sp>
       <p:sp>
         <p:nvSpPr>
-          <p:cNvPr id="47" name="TextBox 46"/>
-          <p:cNvSpPr txBox="1"/>
-          <p:nvPr/>
-        </p:nvSpPr>
-        <p:spPr>
-          <a:xfrm>
-            <a:off x="10579608" y="4315968"/>
-            <a:ext cx="457200" cy="310896"/>
+          <p:cNvPr id="51" name="TextBox 50"/>
+          <p:cNvSpPr txBox="1"/>
+          <p:nvPr/>
+        </p:nvSpPr>
+        <p:spPr>
+          <a:xfrm>
+            <a:off x="10570463" y="4361688"/>
+            <a:ext cx="438912" cy="292608"/>
           </a:xfrm>
           <a:prstGeom prst="rect">
             <a:avLst/>
@@ -10295,13 +10454,13 @@
       </p:sp>
       <p:sp>
         <p:nvSpPr>
-          <p:cNvPr id="48" name="TextBox 47"/>
-          <p:cNvSpPr txBox="1"/>
-          <p:nvPr/>
-        </p:nvSpPr>
-        <p:spPr>
-          <a:xfrm>
-            <a:off x="11073384" y="4352544"/>
+          <p:cNvPr id="52" name="TextBox 51"/>
+          <p:cNvSpPr txBox="1"/>
+          <p:nvPr/>
+        </p:nvSpPr>
+        <p:spPr>
+          <a:xfrm>
+            <a:off x="11045951" y="4389120"/>
             <a:ext cx="365760" cy="274320"/>
           </a:xfrm>
           <a:prstGeom prst="rect">
@@ -10330,14 +10489,14 @@
       </p:sp>
       <p:cxnSp>
         <p:nvCxnSpPr>
-          <p:cNvPr id="49" name="Connector 48"/>
+          <p:cNvPr id="53" name="Connector 52"/>
           <p:cNvCxnSpPr/>
           <p:nvPr/>
         </p:nvCxnSpPr>
         <p:spPr>
           <a:xfrm>
-            <a:off x="8252460" y="4791456"/>
-            <a:ext cx="0" cy="256032"/>
+            <a:off x="8252460" y="4919472"/>
+            <a:ext cx="0" cy="182880"/>
           </a:xfrm>
           <a:prstGeom prst="bentConnector3">
             <a:avLst/>
@@ -10366,13 +10525,13 @@
       </p:cxnSp>
       <p:sp>
         <p:nvSpPr>
-          <p:cNvPr id="50" name="Isosceles Triangle 49"/>
+          <p:cNvPr id="54" name="Isosceles Triangle 53"/>
           <p:cNvSpPr/>
           <p:nvPr/>
         </p:nvSpPr>
         <p:spPr>
           <a:xfrm rot="10800000">
-            <a:off x="8183880" y="4978907"/>
+            <a:off x="8183880" y="5033772"/>
             <a:ext cx="137160" cy="137160"/>
           </a:xfrm>
           <a:prstGeom prst="triangle">
@@ -10410,13 +10569,13 @@
       </p:sp>
       <p:sp>
         <p:nvSpPr>
-          <p:cNvPr id="51" name="Rounded Rectangle 50"/>
+          <p:cNvPr id="55" name="Rounded Rectangle 54"/>
           <p:cNvSpPr/>
           <p:nvPr/>
         </p:nvSpPr>
         <p:spPr>
           <a:xfrm>
-            <a:off x="5074920" y="5065776"/>
+            <a:off x="5074920" y="5102352"/>
             <a:ext cx="6355080" cy="658368"/>
           </a:xfrm>
           <a:prstGeom prst="roundRect">
@@ -10465,13 +10624,13 @@
       </p:sp>
       <p:sp>
         <p:nvSpPr>
-          <p:cNvPr id="52" name="TextBox 51"/>
-          <p:cNvSpPr txBox="1"/>
-          <p:nvPr/>
-        </p:nvSpPr>
-        <p:spPr>
-          <a:xfrm>
-            <a:off x="5074920" y="5184648"/>
+          <p:cNvPr id="56" name="TextBox 55"/>
+          <p:cNvSpPr txBox="1"/>
+          <p:nvPr/>
+        </p:nvSpPr>
+        <p:spPr>
+          <a:xfrm>
+            <a:off x="5074920" y="5221224"/>
             <a:ext cx="6355080" cy="256032"/>
           </a:xfrm>
           <a:prstGeom prst="rect">
@@ -10500,13 +10659,13 @@
       </p:sp>
       <p:sp>
         <p:nvSpPr>
-          <p:cNvPr id="53" name="TextBox 52"/>
-          <p:cNvSpPr txBox="1"/>
-          <p:nvPr/>
-        </p:nvSpPr>
-        <p:spPr>
-          <a:xfrm>
-            <a:off x="5074920" y="5440680"/>
+          <p:cNvPr id="57" name="TextBox 56"/>
+          <p:cNvSpPr txBox="1"/>
+          <p:nvPr/>
+        </p:nvSpPr>
+        <p:spPr>
+          <a:xfrm>
+            <a:off x="5074920" y="5477256"/>
             <a:ext cx="6355080" cy="219456"/>
           </a:xfrm>
           <a:prstGeom prst="rect">
@@ -10535,13 +10694,13 @@
       </p:sp>
       <p:cxnSp>
         <p:nvCxnSpPr>
-          <p:cNvPr id="54" name="Connector 53"/>
+          <p:cNvPr id="58" name="Connector 57"/>
           <p:cNvCxnSpPr/>
           <p:nvPr/>
         </p:nvCxnSpPr>
         <p:spPr>
           <a:xfrm>
-            <a:off x="3429000" y="3246120"/>
+            <a:off x="3429000" y="3200400"/>
             <a:ext cx="1600200" cy="0"/>
           </a:xfrm>
           <a:prstGeom prst="bentConnector3">
@@ -10572,13 +10731,13 @@
       </p:cxnSp>
       <p:sp>
         <p:nvSpPr>
-          <p:cNvPr id="55" name="Isosceles Triangle 54"/>
+          <p:cNvPr id="59" name="Isosceles Triangle 58"/>
           <p:cNvSpPr/>
           <p:nvPr/>
         </p:nvSpPr>
         <p:spPr>
           <a:xfrm rot="5400000">
-            <a:off x="4960620" y="3177539"/>
+            <a:off x="4960620" y="3131820"/>
             <a:ext cx="137160" cy="137160"/>
           </a:xfrm>
           <a:prstGeom prst="triangle">
@@ -10616,13 +10775,13 @@
       </p:sp>
       <p:sp>
         <p:nvSpPr>
-          <p:cNvPr id="56" name="TextBox 55"/>
-          <p:cNvSpPr txBox="1"/>
-          <p:nvPr/>
-        </p:nvSpPr>
-        <p:spPr>
-          <a:xfrm>
-            <a:off x="3474720" y="2999232"/>
+          <p:cNvPr id="60" name="TextBox 59"/>
+          <p:cNvSpPr txBox="1"/>
+          <p:nvPr/>
+        </p:nvSpPr>
+        <p:spPr>
+          <a:xfrm>
+            <a:off x="3474720" y="2962656"/>
             <a:ext cx="1645919" cy="219456"/>
           </a:xfrm>
           <a:prstGeom prst="rect">
@@ -10651,13 +10810,129 @@
       </p:sp>
       <p:cxnSp>
         <p:nvCxnSpPr>
-          <p:cNvPr id="57" name="Connector 56"/>
+          <p:cNvPr id="61" name="Connector 60"/>
           <p:cNvCxnSpPr/>
           <p:nvPr/>
         </p:nvCxnSpPr>
         <p:spPr>
-          <a:xfrm>
-            <a:off x="3429000" y="5394960"/>
+          <a:xfrm flipH="1">
+            <a:off x="3456432" y="4498848"/>
+            <a:ext cx="1618488" cy="0"/>
+          </a:xfrm>
+          <a:prstGeom prst="bentConnector3">
+            <a:avLst/>
+          </a:prstGeom>
+          <a:ln w="19050">
+            <a:solidFill>
+              <a:srgbClr val="5B9DF9"/>
+            </a:solidFill>
+            <a:prstDash val="dash"/>
+          </a:ln>
+          <a:effectLst/>
+        </p:spPr>
+        <p:style>
+          <a:lnRef idx="2">
+            <a:schemeClr val="accent1"/>
+          </a:lnRef>
+          <a:fillRef idx="0">
+            <a:schemeClr val="accent1"/>
+          </a:fillRef>
+          <a:effectRef idx="1">
+            <a:schemeClr val="accent1"/>
+          </a:effectRef>
+          <a:fontRef idx="minor">
+            <a:schemeClr val="tx1"/>
+          </a:fontRef>
+        </p:style>
+      </p:cxnSp>
+      <p:sp>
+        <p:nvSpPr>
+          <p:cNvPr id="62" name="Isosceles Triangle 61"/>
+          <p:cNvSpPr/>
+          <p:nvPr/>
+        </p:nvSpPr>
+        <p:spPr>
+          <a:xfrm rot="16200000">
+            <a:off x="3387851" y="4430268"/>
+            <a:ext cx="137160" cy="137160"/>
+          </a:xfrm>
+          <a:prstGeom prst="triangle">
+            <a:avLst/>
+          </a:prstGeom>
+          <a:solidFill>
+            <a:srgbClr val="5B9DF9"/>
+          </a:solidFill>
+          <a:ln>
+            <a:noFill/>
+          </a:ln>
+          <a:effectLst/>
+        </p:spPr>
+        <p:style>
+          <a:lnRef idx="1">
+            <a:schemeClr val="accent1"/>
+          </a:lnRef>
+          <a:fillRef idx="3">
+            <a:schemeClr val="accent1"/>
+          </a:fillRef>
+          <a:effectRef idx="2">
+            <a:schemeClr val="accent1"/>
+          </a:effectRef>
+          <a:fontRef idx="minor">
+            <a:schemeClr val="lt1"/>
+          </a:fontRef>
+        </p:style>
+        <p:txBody>
+          <a:bodyPr rtlCol="0" anchor="ctr"/>
+          <a:lstStyle/>
+          <a:p>
+            <a:pPr algn="ctr"/>
+          </a:p>
+        </p:txBody>
+      </p:sp>
+      <p:sp>
+        <p:nvSpPr>
+          <p:cNvPr id="63" name="TextBox 62"/>
+          <p:cNvSpPr txBox="1"/>
+          <p:nvPr/>
+        </p:nvSpPr>
+        <p:spPr>
+          <a:xfrm>
+            <a:off x="3474720" y="4261104"/>
+            <a:ext cx="1645919" cy="219456"/>
+          </a:xfrm>
+          <a:prstGeom prst="rect">
+            <a:avLst/>
+          </a:prstGeom>
+          <a:noFill/>
+        </p:spPr>
+        <p:txBody>
+          <a:bodyPr wrap="square" anchor="t" lIns="0" rIns="0" tIns="0" bIns="0">
+            <a:spAutoFit/>
+          </a:bodyPr>
+          <a:lstStyle/>
+          <a:p>
+            <a:pPr algn="ctr"/>
+            <a:r>
+              <a:rPr sz="900" b="0" i="1">
+                <a:solidFill>
+                  <a:srgbClr val="5B9DF9"/>
+                </a:solidFill>
+                <a:latin typeface="Calibri"/>
+              </a:rPr>
+              <a:t>recall · aged gestalts</a:t>
+            </a:r>
+          </a:p>
+        </p:txBody>
+      </p:sp>
+      <p:cxnSp>
+        <p:nvCxnSpPr>
+          <p:cNvPr id="64" name="Connector 63"/>
+          <p:cNvCxnSpPr/>
+          <p:nvPr/>
+        </p:nvCxnSpPr>
+        <p:spPr>
+          <a:xfrm>
+            <a:off x="3429000" y="5431536"/>
             <a:ext cx="1600200" cy="0"/>
           </a:xfrm>
           <a:prstGeom prst="bentConnector3">
@@ -10688,13 +10963,13 @@
       </p:cxnSp>
       <p:sp>
         <p:nvSpPr>
-          <p:cNvPr id="58" name="Isosceles Triangle 57"/>
+          <p:cNvPr id="65" name="Isosceles Triangle 64"/>
           <p:cNvSpPr/>
           <p:nvPr/>
         </p:nvSpPr>
         <p:spPr>
           <a:xfrm rot="5400000">
-            <a:off x="4960620" y="5326380"/>
+            <a:off x="4960620" y="5362956"/>
             <a:ext cx="137160" cy="137160"/>
           </a:xfrm>
           <a:prstGeom prst="triangle">
@@ -10732,13 +11007,13 @@
       </p:sp>
       <p:sp>
         <p:nvSpPr>
-          <p:cNvPr id="59" name="TextBox 58"/>
-          <p:cNvSpPr txBox="1"/>
-          <p:nvPr/>
-        </p:nvSpPr>
-        <p:spPr>
-          <a:xfrm>
-            <a:off x="3474720" y="5148072"/>
+          <p:cNvPr id="66" name="TextBox 65"/>
+          <p:cNvSpPr txBox="1"/>
+          <p:nvPr/>
+        </p:nvSpPr>
+        <p:spPr>
+          <a:xfrm>
+            <a:off x="3474720" y="5193792"/>
             <a:ext cx="1645919" cy="219456"/>
           </a:xfrm>
           <a:prstGeom prst="rect">
@@ -10767,7 +11042,7 @@
       </p:sp>
       <p:cxnSp>
         <p:nvCxnSpPr>
-          <p:cNvPr id="60" name="Connector 59"/>
+          <p:cNvPr id="67" name="Connector 66"/>
           <p:cNvCxnSpPr/>
           <p:nvPr/>
         </p:nvCxnSpPr>
@@ -10803,14 +11078,14 @@
       </p:cxnSp>
       <p:sp>
         <p:nvSpPr>
-          <p:cNvPr id="61" name="TextBox 60"/>
+          <p:cNvPr id="68" name="TextBox 67"/>
           <p:cNvSpPr txBox="1"/>
           <p:nvPr/>
         </p:nvSpPr>
         <p:spPr>
           <a:xfrm>
             <a:off x="5532120" y="5943600"/>
-            <a:ext cx="2743200" cy="219456"/>
+            <a:ext cx="2926080" cy="219456"/>
           </a:xfrm>
           <a:prstGeom prst="rect">
             <a:avLst/>
@@ -10831,20 +11106,20 @@
                 </a:solidFill>
                 <a:latin typeface="Calibri"/>
               </a:rPr>
-              <a:t>data flow · writes self-state</a:t>
+              <a:t>generation flow · writes self-state</a:t>
             </a:r>
           </a:p>
         </p:txBody>
       </p:sp>
       <p:cxnSp>
         <p:nvCxnSpPr>
-          <p:cNvPr id="62" name="Connector 61"/>
+          <p:cNvPr id="69" name="Connector 68"/>
           <p:cNvCxnSpPr/>
           <p:nvPr/>
         </p:nvCxnSpPr>
         <p:spPr>
           <a:xfrm>
-            <a:off x="8275320" y="6053328"/>
+            <a:off x="8503920" y="6053328"/>
             <a:ext cx="365760" cy="0"/>
           </a:xfrm>
           <a:prstGeom prst="bentConnector3">
@@ -10875,13 +11150,13 @@
       </p:cxnSp>
       <p:sp>
         <p:nvSpPr>
-          <p:cNvPr id="63" name="TextBox 62"/>
-          <p:cNvSpPr txBox="1"/>
-          <p:nvPr/>
-        </p:nvSpPr>
-        <p:spPr>
-          <a:xfrm>
-            <a:off x="8732520" y="5943600"/>
+          <p:cNvPr id="70" name="TextBox 69"/>
+          <p:cNvSpPr txBox="1"/>
+          <p:nvPr/>
+        </p:nvSpPr>
+        <p:spPr>
+          <a:xfrm>
+            <a:off x="8961120" y="5943600"/>
             <a:ext cx="2743200" cy="219456"/>
           </a:xfrm>
           <a:prstGeom prst="rect">
@@ -10903,14 +11178,14 @@
                 </a:solidFill>
                 <a:latin typeface="Calibri"/>
               </a:rPr>
-              <a:t>read-only cross-attention</a:t>
-            </a:r>
-          </a:p>
-        </p:txBody>
-      </p:sp>
-      <p:sp>
-        <p:nvSpPr>
-          <p:cNvPr id="64" name="TextBox 63"/>
+              <a:t>read-only cross-attention / recall</a:t>
+            </a:r>
+          </a:p>
+        </p:txBody>
+      </p:sp>
+      <p:sp>
+        <p:nvSpPr>
+          <p:cNvPr id="71" name="TextBox 70"/>
           <p:cNvSpPr txBox="1"/>
           <p:nvPr/>
         </p:nvSpPr>
@@ -10945,7 +11220,7 @@
       </p:sp>
       <p:sp>
         <p:nvSpPr>
-          <p:cNvPr id="65" name="TextBox 64"/>
+          <p:cNvPr id="72" name="TextBox 71"/>
           <p:cNvSpPr txBox="1"/>
           <p:nvPr/>
         </p:nvSpPr>
@@ -16669,7 +16944,7 @@
                 </a:solidFill>
                 <a:latin typeface="Cambria"/>
               </a:rPr>
-              <a:t>At matched compute, competitive with a standard GPT</a:t>
+              <a:t>Ahead of a width-matched GPT, behind a param-matched one</a:t>
             </a:r>
           </a:p>
         </p:txBody>
@@ -16708,7 +16983,7 @@
                 </a:solidFill>
                 <a:latin typeface="Calibri"/>
               </a:rPr>
-              <a:t>Memorizing one Wikipedia page — same gpt2 tokenizer, optimizer, schedule &amp; step budget; </a:t>
+              <a:t>Memorizing one Wikipedia page — same gpt2 tokenizer, optimizer &amp; schedule (the latent needs 4× the batch to memorize); </a:t>
             </a:r>
             <a:r>
               <a:rPr sz="1300" b="1" i="0">
@@ -16914,7 +17189,7 @@
                 </a:solidFill>
                 <a:latin typeface="Cambria"/>
               </a:rPr>
-              <a:t>Both memorize the page</a:t>
+              <a:t>Beats the width-matched GPT</a:t>
             </a:r>
           </a:p>
         </p:txBody>
@@ -16953,7 +17228,7 @@
                 </a:solidFill>
                 <a:latin typeface="Calibri"/>
               </a:rPr>
-              <a:t>Latent grounded-only reconstruction → ppl ≈ 1.0, matching the 44.7M same-params GPT (≈ 1.1).</a:t>
+              <a:t>The 14.1M same-compute GPT (d=192) plateaus at ≈ 487; the latent, same width, memorizes to ≈ 38.</a:t>
             </a:r>
           </a:p>
         </p:txBody>
@@ -17072,7 +17347,7 @@
                 </a:solidFill>
                 <a:latin typeface="Cambria"/>
               </a:rPr>
-              <a:t>Matched-width GPT can't</a:t>
+              <a:t>A param-matched GPT is more efficient</a:t>
             </a:r>
           </a:p>
         </p:txBody>
@@ -17111,7 +17386,7 @@
                 </a:solidFill>
                 <a:latin typeface="Calibri"/>
               </a:rPr>
-              <a:t>The 14.1M same-compute GPT (d=192) plateaus at ≈ 484 — same width, no bottleneck to lean on.</a:t>
+              <a:t>The 44.7M same-params GPT reaches ≈ 2; the latent floors at ≈ 38 — the 192-d thought bottleneck caps exact reconstruction — and only at 4× the batch.</a:t>
             </a:r>
           </a:p>
         </p:txBody>
@@ -17269,7 +17544,7 @@
                 </a:solidFill>
                 <a:latin typeface="Calibri"/>
               </a:rPr>
-              <a:t>Under the full A→E curriculum the latent model sits at 936: self-supervision trades page-fit for generalization.</a:t>
+              <a:t>Under the full A→E curriculum the latent model sits at ≈ 957: self-supervision trades page-fit for generalization.</a:t>
             </a:r>
           </a:p>
         </p:txBody>
@@ -17308,7 +17583,7 @@
                 </a:solidFill>
                 <a:latin typeface="Calibri"/>
               </a:rPr>
-              <a:t>Chance ≈ 50,262.  </a:t>
+              <a:t>Chance ≈ 50,257.  </a:t>
             </a:r>
             <a:r>
               <a:rPr sz="1000" b="0" i="1">

</xml_diff>